<commit_message>
update for day 2
</commit_message>
<xml_diff>
--- a/day2/slides/review.pptx
+++ b/day2/slides/review.pptx
@@ -232,7 +232,7 @@
           <a:p>
             <a:fld id="{3E00069D-D4B1-DA43-B156-1FB9179E1249}" type="datetimeFigureOut">
               <a:rPr lang="en-US" smtClean="0"/>
-              <a:t>5/10/26</a:t>
+              <a:t>5/12/26</a:t>
             </a:fld>
             <a:endParaRPr lang="en-US"/>
           </a:p>
@@ -3108,7 +3108,7 @@
           <a:p>
             <a:fld id="{51673806-0BCD-1F42-BAA8-2011034B3C6A}" type="datetimeFigureOut">
               <a:rPr lang="en-US" smtClean="0"/>
-              <a:t>5/10/26</a:t>
+              <a:t>5/12/26</a:t>
             </a:fld>
             <a:endParaRPr lang="en-US" dirty="0"/>
           </a:p>
@@ -3521,7 +3521,7 @@
           <a:p>
             <a:fld id="{51673806-0BCD-1F42-BAA8-2011034B3C6A}" type="datetimeFigureOut">
               <a:rPr lang="en-US" smtClean="0"/>
-              <a:t>5/10/26</a:t>
+              <a:t>5/12/26</a:t>
             </a:fld>
             <a:endParaRPr lang="en-US" dirty="0"/>
           </a:p>
@@ -3852,7 +3852,7 @@
           <a:p>
             <a:fld id="{51673806-0BCD-1F42-BAA8-2011034B3C6A}" type="datetimeFigureOut">
               <a:rPr lang="en-US" smtClean="0"/>
-              <a:t>5/10/26</a:t>
+              <a:t>5/12/26</a:t>
             </a:fld>
             <a:endParaRPr lang="en-US" dirty="0"/>
           </a:p>
@@ -4252,7 +4252,7 @@
           <a:p>
             <a:fld id="{51673806-0BCD-1F42-BAA8-2011034B3C6A}" type="datetimeFigureOut">
               <a:rPr lang="en-US" smtClean="0"/>
-              <a:t>5/10/26</a:t>
+              <a:t>5/12/26</a:t>
             </a:fld>
             <a:endParaRPr lang="en-US" dirty="0"/>
           </a:p>
@@ -4815,7 +4815,7 @@
           <a:p>
             <a:fld id="{51673806-0BCD-1F42-BAA8-2011034B3C6A}" type="datetimeFigureOut">
               <a:rPr lang="en-US" smtClean="0"/>
-              <a:t>5/10/26</a:t>
+              <a:t>5/12/26</a:t>
             </a:fld>
             <a:endParaRPr lang="en-US" dirty="0"/>
           </a:p>
@@ -5491,7 +5491,7 @@
           <a:p>
             <a:fld id="{51673806-0BCD-1F42-BAA8-2011034B3C6A}" type="datetimeFigureOut">
               <a:rPr lang="en-US" smtClean="0"/>
-              <a:t>5/10/26</a:t>
+              <a:t>5/12/26</a:t>
             </a:fld>
             <a:endParaRPr lang="en-US" dirty="0"/>
           </a:p>
@@ -6396,7 +6396,7 @@
           <a:p>
             <a:fld id="{51673806-0BCD-1F42-BAA8-2011034B3C6A}" type="datetimeFigureOut">
               <a:rPr lang="en-US" smtClean="0"/>
-              <a:t>5/10/26</a:t>
+              <a:t>5/12/26</a:t>
             </a:fld>
             <a:endParaRPr lang="en-US" dirty="0"/>
           </a:p>
@@ -6704,7 +6704,7 @@
           <a:p>
             <a:fld id="{51673806-0BCD-1F42-BAA8-2011034B3C6A}" type="datetimeFigureOut">
               <a:rPr lang="en-US" smtClean="0"/>
-              <a:t>5/10/26</a:t>
+              <a:t>5/12/26</a:t>
             </a:fld>
             <a:endParaRPr lang="en-US" dirty="0"/>
           </a:p>
@@ -6963,7 +6963,7 @@
           <a:p>
             <a:fld id="{51673806-0BCD-1F42-BAA8-2011034B3C6A}" type="datetimeFigureOut">
               <a:rPr lang="en-US" smtClean="0"/>
-              <a:t>5/10/26</a:t>
+              <a:t>5/12/26</a:t>
             </a:fld>
             <a:endParaRPr lang="en-US" dirty="0"/>
           </a:p>
@@ -7286,7 +7286,7 @@
           <a:p>
             <a:fld id="{51673806-0BCD-1F42-BAA8-2011034B3C6A}" type="datetimeFigureOut">
               <a:rPr lang="en-US" smtClean="0"/>
-              <a:t>5/10/26</a:t>
+              <a:t>5/12/26</a:t>
             </a:fld>
             <a:endParaRPr lang="en-US" dirty="0"/>
           </a:p>
@@ -7670,7 +7670,7 @@
           <a:p>
             <a:fld id="{51673806-0BCD-1F42-BAA8-2011034B3C6A}" type="datetimeFigureOut">
               <a:rPr lang="en-US" smtClean="0"/>
-              <a:t>5/10/26</a:t>
+              <a:t>5/12/26</a:t>
             </a:fld>
             <a:endParaRPr lang="en-US" dirty="0"/>
           </a:p>
@@ -8046,7 +8046,7 @@
           <a:p>
             <a:fld id="{51673806-0BCD-1F42-BAA8-2011034B3C6A}" type="datetimeFigureOut">
               <a:rPr lang="en-US" smtClean="0"/>
-              <a:t>5/10/26</a:t>
+              <a:t>5/12/26</a:t>
             </a:fld>
             <a:endParaRPr lang="en-US" dirty="0"/>
           </a:p>
@@ -8552,7 +8552,7 @@
           <a:p>
             <a:fld id="{51673806-0BCD-1F42-BAA8-2011034B3C6A}" type="datetimeFigureOut">
               <a:rPr lang="en-US" smtClean="0"/>
-              <a:t>5/10/26</a:t>
+              <a:t>5/12/26</a:t>
             </a:fld>
             <a:endParaRPr lang="en-US" dirty="0"/>
           </a:p>
@@ -8809,7 +8809,7 @@
           <a:p>
             <a:fld id="{51673806-0BCD-1F42-BAA8-2011034B3C6A}" type="datetimeFigureOut">
               <a:rPr lang="en-US" smtClean="0"/>
-              <a:t>5/10/26</a:t>
+              <a:t>5/12/26</a:t>
             </a:fld>
             <a:endParaRPr lang="en-US" dirty="0"/>
           </a:p>
@@ -8967,7 +8967,7 @@
           <a:p>
             <a:fld id="{51673806-0BCD-1F42-BAA8-2011034B3C6A}" type="datetimeFigureOut">
               <a:rPr lang="en-US" smtClean="0"/>
-              <a:t>5/10/26</a:t>
+              <a:t>5/12/26</a:t>
             </a:fld>
             <a:endParaRPr lang="en-US" dirty="0"/>
           </a:p>
@@ -9357,7 +9357,7 @@
           <a:p>
             <a:fld id="{51673806-0BCD-1F42-BAA8-2011034B3C6A}" type="datetimeFigureOut">
               <a:rPr lang="en-US" smtClean="0"/>
-              <a:t>5/10/26</a:t>
+              <a:t>5/12/26</a:t>
             </a:fld>
             <a:endParaRPr lang="en-US" dirty="0"/>
           </a:p>
@@ -9765,7 +9765,7 @@
           <a:p>
             <a:fld id="{51673806-0BCD-1F42-BAA8-2011034B3C6A}" type="datetimeFigureOut">
               <a:rPr lang="en-US" smtClean="0"/>
-              <a:t>5/10/26</a:t>
+              <a:t>5/12/26</a:t>
             </a:fld>
             <a:endParaRPr lang="en-US" dirty="0"/>
           </a:p>
@@ -10010,7 +10010,7 @@
             <a:fld id="{51673806-0BCD-1F42-BAA8-2011034B3C6A}" type="datetimeFigureOut">
               <a:rPr lang="en-US" smtClean="0"/>
               <a:pPr/>
-              <a:t>5/10/26</a:t>
+              <a:t>5/12/26</a:t>
             </a:fld>
             <a:endParaRPr lang="en-US" dirty="0"/>
           </a:p>
@@ -10486,7 +10486,7 @@
           <a:p>
             <a:r>
               <a:rPr lang="en-US" dirty="0"/>
-              <a:t>Slides by: James W. Johnson</a:t>
+              <a:t>Slides by: James W. Johnson and Jackson Datkuliak</a:t>
             </a:r>
           </a:p>
         </p:txBody>
@@ -14828,7 +14828,9 @@
           </a:xfrm>
         </p:spPr>
         <p:txBody>
-          <a:bodyPr/>
+          <a:bodyPr>
+            <a:normAutofit fontScale="92500" lnSpcReduction="10000"/>
+          </a:bodyPr>
           <a:lstStyle/>
           <a:p>
             <a:pPr marL="0" marR="0" lvl="0" indent="0" defTabSz="914400" eaLnBrk="1" fontAlgn="auto" latinLnBrk="0" hangingPunct="1">
@@ -14923,7 +14925,7 @@
             </a:pPr>
             <a:r>
               <a:rPr lang="en-US" dirty="0"/>
-              <a:t>Numeric operations </a:t>
+              <a:t>Arithmetic operations </a:t>
             </a:r>
           </a:p>
           <a:p>
@@ -14946,7 +14948,7 @@
             </a:pPr>
             <a:r>
               <a:rPr lang="en-US" dirty="0"/>
-              <a:t>	=, ==, +, -, *, /, //, %, +=, -=, *=, /=, //=, %= </a:t>
+              <a:t>	+, -, *, /, %, **, // </a:t>
             </a:r>
           </a:p>
           <a:p>
@@ -14969,8 +14971,61 @@
             </a:pPr>
             <a:r>
               <a:rPr lang="en-US" dirty="0"/>
-              <a:t>	Recall: x += y is the same as x = x + y </a:t>
-            </a:r>
+              <a:t>	x += y is the same as x = x + y (can add = to other operators)</a:t>
+            </a:r>
+          </a:p>
+          <a:p>
+            <a:pPr marL="0" indent="0">
+              <a:lnSpc>
+                <a:spcPct val="100000"/>
+              </a:lnSpc>
+              <a:spcBef>
+                <a:spcPts val="0"/>
+              </a:spcBef>
+              <a:buNone/>
+              <a:defRPr/>
+            </a:pPr>
+            <a:r>
+              <a:rPr lang="en-US" dirty="0"/>
+              <a:t>	3 / 2 returns 1.5, but 3 // 2 returns 1  (division vs. floor </a:t>
+            </a:r>
+            <a:r>
+              <a:rPr lang="en-US" dirty="0" err="1"/>
+              <a:t>divison</a:t>
+            </a:r>
+            <a:r>
+              <a:rPr lang="en-US" dirty="0"/>
+              <a:t>)</a:t>
+            </a:r>
+          </a:p>
+          <a:p>
+            <a:pPr marL="0" indent="0">
+              <a:lnSpc>
+                <a:spcPct val="100000"/>
+              </a:lnSpc>
+              <a:spcBef>
+                <a:spcPts val="0"/>
+              </a:spcBef>
+              <a:buNone/>
+              <a:defRPr/>
+            </a:pPr>
+            <a:r>
+              <a:rPr lang="en-US" dirty="0"/>
+              <a:t>	5 % 2 returns 1; 5 % 3 returns 2; 5 % 1 returns 0 (modulo)</a:t>
+            </a:r>
+          </a:p>
+          <a:p>
+            <a:pPr marL="0" indent="0">
+              <a:lnSpc>
+                <a:spcPct val="100000"/>
+              </a:lnSpc>
+              <a:spcBef>
+                <a:spcPts val="0"/>
+              </a:spcBef>
+              <a:buNone/>
+              <a:defRPr/>
+            </a:pPr>
+            <a:endParaRPr lang="en-US" dirty="0"/>
           </a:p>
           <a:p>
             <a:pPr marL="0" marR="0" lvl="0" indent="0" defTabSz="914400" eaLnBrk="1" fontAlgn="auto" latinLnBrk="0" hangingPunct="1">
@@ -14990,7 +15045,10 @@
               <a:tabLst/>
               <a:defRPr/>
             </a:pPr>
-            <a:endParaRPr lang="en-US" dirty="0"/>
+            <a:r>
+              <a:rPr lang="en-US" dirty="0"/>
+              <a:t>Comparison operations</a:t>
+            </a:r>
           </a:p>
           <a:p>
             <a:pPr marL="0" marR="0" lvl="0" indent="0" defTabSz="914400" eaLnBrk="1" fontAlgn="auto" latinLnBrk="0" hangingPunct="1">
@@ -15012,21 +15070,7 @@
             </a:pPr>
             <a:r>
               <a:rPr lang="en-US" dirty="0"/>
-              <a:t>/ vs. //: true division vs. floor division (i.e. integer quotient) </a:t>
-            </a:r>
-          </a:p>
-          <a:p>
-            <a:pPr lvl="1">
-              <a:lnSpc>
-                <a:spcPct val="100000"/>
-              </a:lnSpc>
-              <a:spcBef>
-                <a:spcPts val="0"/>
-              </a:spcBef>
-            </a:pPr>
-            <a:r>
-              <a:rPr lang="en-US" dirty="0"/>
-              <a:t>3 / 2 returns 1.5, but 3 // 2 returns 1 </a:t>
+              <a:t>	==, !=, &lt;, &gt;, &lt;=, &gt;=</a:t>
             </a:r>
           </a:p>
           <a:p>
@@ -15050,6 +15094,32 @@
             <a:endParaRPr lang="en-US" dirty="0"/>
           </a:p>
           <a:p>
+            <a:pPr marL="0" lvl="0" indent="0">
+              <a:lnSpc>
+                <a:spcPct val="100000"/>
+              </a:lnSpc>
+              <a:spcBef>
+                <a:spcPts val="0"/>
+              </a:spcBef>
+              <a:buNone/>
+              <a:defRPr/>
+            </a:pPr>
+            <a:r>
+              <a:rPr lang="en-US" dirty="0"/>
+              <a:t>Look at the pages under Python Operators: </a:t>
+            </a:r>
+            <a:r>
+              <a:rPr lang="en-US" dirty="0">
+                <a:hlinkClick r:id="rId3"/>
+              </a:rPr>
+              <a:t>https://www.w3schools.com/python/python_operators.asp</a:t>
+            </a:r>
+            <a:r>
+              <a:rPr lang="en-US" dirty="0"/>
+              <a:t> </a:t>
+            </a:r>
+          </a:p>
+          <a:p>
             <a:pPr marL="0" marR="0" lvl="0" indent="0" defTabSz="914400" eaLnBrk="1" fontAlgn="auto" latinLnBrk="0" hangingPunct="1">
               <a:lnSpc>
                 <a:spcPct val="100000"/>
@@ -15067,24 +15137,7 @@
               <a:tabLst/>
               <a:defRPr/>
             </a:pPr>
-            <a:r>
-              <a:rPr lang="en-US" dirty="0"/>
-              <a:t>%: modulo (calculates remainder)  </a:t>
-            </a:r>
-          </a:p>
-          <a:p>
-            <a:pPr lvl="1">
-              <a:lnSpc>
-                <a:spcPct val="100000"/>
-              </a:lnSpc>
-              <a:spcBef>
-                <a:spcPts val="0"/>
-              </a:spcBef>
-            </a:pPr>
-            <a:r>
-              <a:rPr lang="en-US" dirty="0"/>
-              <a:t>5 % 2 returns 1; 5 % 3 returns 2; 5 % 1 returns 0 </a:t>
-            </a:r>
+            <a:endParaRPr lang="en-US" dirty="0"/>
           </a:p>
         </p:txBody>
       </p:sp>
@@ -16127,7 +16180,7 @@
             </a:r>
             <a:r>
               <a:rPr lang="en-US" dirty="0"/>
-              <a:t>(). That function call has some overhead, which is causing the slow down for the smaller array sizes. However, that overhead is dwarfed in comparison to the gain in speed that C gives you once the array is big.</a:t>
+              <a:t>(). That function call has some overhead, which is causing the slow down for the smaller array sizes. However, that overhead is dwarfed by the gain in speed that C gives you once the array is big.</a:t>
             </a:r>
           </a:p>
           <a:p>
@@ -16148,7 +16201,7 @@
             </a:pPr>
             <a:r>
               <a:rPr lang="en-US" dirty="0"/>
-              <a:t>LLMs are actually really good at making optimizations like this. You can paste a snippet of your code into Claude and ask something like: ”I am working with x type of data and want to optimize for y workload” and it will tell you what you need to change (or don’t) to get the best performance!</a:t>
+              <a:t>LLMs are really good at making optimizations like this. You can paste a snippet of your code into Claude and ask something like: ”I am working with x type of data and want to optimize for y workload” and it will tell you what you need to change (or don’t) to get the best performance!</a:t>
             </a:r>
           </a:p>
         </p:txBody>

</xml_diff>